<commit_message>
Update 꼬리 잡기 assets and add ZIP slides
Co-Authored-By: Claude Opus 4.6 (1M context) <noreply@anthropic.com>
</commit_message>
<xml_diff>
--- a/public/downloads/games/tail-catch/rules.pptx
+++ b/public/downloads/games/tail-catch/rules.pptx
@@ -15,16 +15,12 @@
   <p:notesSz cx="6858000" cy="9144000"/>
   <p:embeddedFontLst>
     <p:embeddedFont>
-      <p:font typeface="Jua" charset="1" panose="00000000000000000000"/>
+      <p:font typeface="무궁화 고딕" charset="1" panose="02020603020101020101"/>
       <p:regular r:id="rId11"/>
     </p:embeddedFont>
     <p:embeddedFont>
-      <p:font typeface="TDTD갬성명조" charset="1" panose="02000503000000000000"/>
+      <p:font typeface="무궁화 고딕 Bold" charset="1" panose="02020603020101020101"/>
       <p:regular r:id="rId12"/>
-    </p:embeddedFont>
-    <p:embeddedFont>
-      <p:font typeface="TDTD가온" charset="1" panose="02000503000000000000"/>
-      <p:regular r:id="rId13"/>
     </p:embeddedFont>
   </p:embeddedFontLst>
   <p:defaultTextStyle>
@@ -3142,8 +3138,8 @@
         </p:nvSpPr>
         <p:spPr>
           <a:xfrm rot="0">
-            <a:off x="1028700" y="3892867"/>
-            <a:ext cx="15555091" cy="2200275"/>
+            <a:off x="1028700" y="4178617"/>
+            <a:ext cx="15555091" cy="1914525"/>
           </a:xfrm>
           <a:prstGeom prst="rect">
             <a:avLst/>
@@ -3165,10 +3161,10 @@
                 <a:solidFill>
                   <a:srgbClr val="FFFAEF"/>
                 </a:solidFill>
-                <a:latin typeface="Jua"/>
-                <a:ea typeface="Jua"/>
-                <a:cs typeface="Jua"/>
-                <a:sym typeface="Jua"/>
+                <a:latin typeface="무궁화 고딕"/>
+                <a:ea typeface="무궁화 고딕"/>
+                <a:cs typeface="무궁화 고딕"/>
+                <a:sym typeface="무궁화 고딕"/>
               </a:rPr>
               <a:t>꼬리 잡기</a:t>
             </a:r>
@@ -3183,8 +3179,8 @@
         </p:nvSpPr>
         <p:spPr>
           <a:xfrm rot="0">
-            <a:off x="15264803" y="9812655"/>
-            <a:ext cx="2637975" cy="474345"/>
+            <a:off x="14683277" y="9822180"/>
+            <a:ext cx="3219502" cy="464820"/>
           </a:xfrm>
           <a:prstGeom prst="rect">
             <a:avLst/>
@@ -3209,10 +3205,10 @@
                 <a:solidFill>
                   <a:srgbClr val="FFFFFF"/>
                 </a:solidFill>
-                <a:latin typeface="TDTD갬성명조"/>
-                <a:ea typeface="TDTD갬성명조"/>
-                <a:cs typeface="TDTD갬성명조"/>
-                <a:sym typeface="TDTD갬성명조"/>
+                <a:latin typeface="무궁화 고딕"/>
+                <a:ea typeface="무궁화 고딕"/>
+                <a:cs typeface="무궁화 고딕"/>
+                <a:sym typeface="무궁화 고딕"/>
               </a:rPr>
               <a:t>ⓒ 2026. Sunday Play</a:t>
             </a:r>
@@ -3361,8 +3357,8 @@
         </p:nvSpPr>
         <p:spPr>
           <a:xfrm rot="0">
-            <a:off x="11392761" y="600705"/>
-            <a:ext cx="5362043" cy="1600200"/>
+            <a:off x="11392761" y="819780"/>
+            <a:ext cx="5362043" cy="1381125"/>
           </a:xfrm>
           <a:prstGeom prst="rect">
             <a:avLst/>
@@ -3384,10 +3380,10 @@
                 <a:solidFill>
                   <a:srgbClr val="FFFAEF"/>
                 </a:solidFill>
-                <a:latin typeface="Jua"/>
-                <a:ea typeface="Jua"/>
-                <a:cs typeface="Jua"/>
-                <a:sym typeface="Jua"/>
+                <a:latin typeface="무궁화 고딕"/>
+                <a:ea typeface="무궁화 고딕"/>
+                <a:cs typeface="무궁화 고딕"/>
+                <a:sym typeface="무궁화 고딕"/>
               </a:rPr>
               <a:t>규칙</a:t>
             </a:r>
@@ -3403,9 +3399,9 @@
         <p:grpSpPr>
           <a:xfrm rot="0">
             <a:off x="309172" y="535073"/>
-            <a:ext cx="10694683" cy="2573620"/>
+            <a:ext cx="10694683" cy="2406534"/>
             <a:chOff x="0" y="0"/>
-            <a:chExt cx="14259577" cy="3431493"/>
+            <a:chExt cx="14259577" cy="3208711"/>
           </a:xfrm>
         </p:grpSpPr>
         <p:sp>
@@ -3416,8 +3412,8 @@
           </p:nvSpPr>
           <p:spPr>
             <a:xfrm rot="0">
-              <a:off x="0" y="1380584"/>
-              <a:ext cx="14259577" cy="2050910"/>
+              <a:off x="0" y="1388378"/>
+              <a:ext cx="14259577" cy="1820333"/>
             </a:xfrm>
             <a:prstGeom prst="rect">
               <a:avLst/>
@@ -3431,18 +3427,18 @@
             <a:p>
               <a:pPr algn="l">
                 <a:lnSpc>
-                  <a:spcPts val="6273"/>
+                  <a:spcPts val="5599"/>
                 </a:lnSpc>
               </a:pPr>
               <a:r>
-                <a:rPr lang="en-US" sz="4480">
+                <a:rPr lang="en-US" sz="3999">
                   <a:solidFill>
                     <a:srgbClr val="FFFAEF"/>
                   </a:solidFill>
-                  <a:latin typeface="TDTD가온"/>
-                  <a:ea typeface="TDTD가온"/>
-                  <a:cs typeface="TDTD가온"/>
-                  <a:sym typeface="TDTD가온"/>
+                  <a:latin typeface="무궁화 고딕"/>
+                  <a:ea typeface="무궁화 고딕"/>
+                  <a:cs typeface="무궁화 고딕"/>
+                  <a:sym typeface="무궁화 고딕"/>
                 </a:rPr>
                 <a:t>팀별 대표를 정합니다.</a:t>
               </a:r>
@@ -3450,18 +3446,18 @@
             <a:p>
               <a:pPr algn="l">
                 <a:lnSpc>
-                  <a:spcPts val="6273"/>
+                  <a:spcPts val="5599"/>
                 </a:lnSpc>
               </a:pPr>
               <a:r>
-                <a:rPr lang="en-US" sz="4480">
+                <a:rPr lang="en-US" sz="3999">
                   <a:solidFill>
                     <a:srgbClr val="FFFAEF"/>
                   </a:solidFill>
-                  <a:latin typeface="TDTD가온"/>
-                  <a:ea typeface="TDTD가온"/>
-                  <a:cs typeface="TDTD가온"/>
-                  <a:sym typeface="TDTD가온"/>
+                  <a:latin typeface="무궁화 고딕"/>
+                  <a:ea typeface="무궁화 고딕"/>
+                  <a:cs typeface="무궁화 고딕"/>
+                  <a:sym typeface="무궁화 고딕"/>
                 </a:rPr>
                 <a:t>대표는 허리 뒤에 꼬리를 꽂습니다.</a:t>
               </a:r>
@@ -3476,8 +3472,8 @@
           </p:nvSpPr>
           <p:spPr>
             <a:xfrm rot="0">
-              <a:off x="0" y="-171450"/>
-              <a:ext cx="9574913" cy="1169217"/>
+              <a:off x="0" y="-66675"/>
+              <a:ext cx="9574913" cy="1062712"/>
             </a:xfrm>
             <a:prstGeom prst="rect">
               <a:avLst/>
@@ -3499,10 +3495,10 @@
                   <a:solidFill>
                     <a:srgbClr val="FFFAEF"/>
                   </a:solidFill>
-                  <a:latin typeface="Jua"/>
-                  <a:ea typeface="Jua"/>
-                  <a:cs typeface="Jua"/>
-                  <a:sym typeface="Jua"/>
+                  <a:latin typeface="무궁화 고딕 Bold"/>
+                  <a:ea typeface="무궁화 고딕 Bold"/>
+                  <a:cs typeface="무궁화 고딕 Bold"/>
+                  <a:sym typeface="무궁화 고딕 Bold"/>
                 </a:rPr>
                 <a:t>STEP 1.</a:t>
               </a:r>
@@ -3519,9 +3515,9 @@
         <p:grpSpPr>
           <a:xfrm rot="0">
             <a:off x="9649747" y="8200435"/>
-            <a:ext cx="8487123" cy="1778769"/>
+            <a:ext cx="8487123" cy="1697862"/>
             <a:chOff x="0" y="0"/>
-            <a:chExt cx="11316164" cy="2371692"/>
+            <a:chExt cx="11316164" cy="2263816"/>
           </a:xfrm>
         </p:grpSpPr>
         <p:sp>
@@ -3532,8 +3528,8 @@
           </p:nvSpPr>
           <p:spPr>
             <a:xfrm rot="0">
-              <a:off x="0" y="1377534"/>
-              <a:ext cx="11143161" cy="994158"/>
+              <a:off x="0" y="1373758"/>
+              <a:ext cx="11143161" cy="890058"/>
             </a:xfrm>
             <a:prstGeom prst="rect">
               <a:avLst/>
@@ -3547,18 +3543,18 @@
             <a:p>
               <a:pPr algn="l">
                 <a:lnSpc>
-                  <a:spcPts val="6284"/>
+                  <a:spcPts val="5600"/>
                 </a:lnSpc>
               </a:pPr>
               <a:r>
-                <a:rPr lang="en-US" sz="4489">
+                <a:rPr lang="en-US" sz="4000">
                   <a:solidFill>
                     <a:srgbClr val="FFFAEF"/>
                   </a:solidFill>
-                  <a:latin typeface="TDTD가온"/>
-                  <a:ea typeface="TDTD가온"/>
-                  <a:cs typeface="TDTD가온"/>
-                  <a:sym typeface="TDTD가온"/>
+                  <a:latin typeface="무궁화 고딕"/>
+                  <a:ea typeface="무궁화 고딕"/>
+                  <a:cs typeface="무궁화 고딕"/>
+                  <a:sym typeface="무궁화 고딕"/>
                 </a:rPr>
                 <a:t>마지막까지 꼬리를 지킨 팀이 우승합니다.</a:t>
               </a:r>
@@ -3573,8 +3569,8 @@
           </p:nvSpPr>
           <p:spPr>
             <a:xfrm rot="0">
-              <a:off x="0" y="-171450"/>
-              <a:ext cx="11316164" cy="1171105"/>
+              <a:off x="0" y="-57150"/>
+              <a:ext cx="11316164" cy="1053029"/>
             </a:xfrm>
             <a:prstGeom prst="rect">
               <a:avLst/>
@@ -3596,10 +3592,10 @@
                   <a:solidFill>
                     <a:srgbClr val="FFFAEF"/>
                   </a:solidFill>
-                  <a:latin typeface="Jua"/>
-                  <a:ea typeface="Jua"/>
-                  <a:cs typeface="Jua"/>
-                  <a:sym typeface="Jua"/>
+                  <a:latin typeface="무궁화 고딕 Bold"/>
+                  <a:ea typeface="무궁화 고딕 Bold"/>
+                  <a:cs typeface="무궁화 고딕 Bold"/>
+                  <a:sym typeface="무궁화 고딕 Bold"/>
                 </a:rPr>
                 <a:t>STEP 3.</a:t>
               </a:r>
@@ -3616,9 +3612,9 @@
         <p:grpSpPr>
           <a:xfrm rot="0">
             <a:off x="5460837" y="4209119"/>
-            <a:ext cx="8612946" cy="2570047"/>
+            <a:ext cx="8612946" cy="2402261"/>
             <a:chOff x="0" y="0"/>
-            <a:chExt cx="11483928" cy="3426730"/>
+            <a:chExt cx="11483928" cy="3203015"/>
           </a:xfrm>
         </p:grpSpPr>
         <p:sp>
@@ -3629,8 +3625,8 @@
           </p:nvSpPr>
           <p:spPr>
             <a:xfrm rot="0">
-              <a:off x="0" y="1375218"/>
-              <a:ext cx="11483928" cy="2051512"/>
+              <a:off x="0" y="1382681"/>
+              <a:ext cx="11483928" cy="1820333"/>
             </a:xfrm>
             <a:prstGeom prst="rect">
               <a:avLst/>
@@ -3644,18 +3640,18 @@
             <a:p>
               <a:pPr algn="l">
                 <a:lnSpc>
-                  <a:spcPts val="6275"/>
+                  <a:spcPts val="5599"/>
                 </a:lnSpc>
               </a:pPr>
               <a:r>
-                <a:rPr lang="en-US" sz="4482">
+                <a:rPr lang="en-US" sz="3999">
                   <a:solidFill>
                     <a:srgbClr val="FFFAEF"/>
                   </a:solidFill>
-                  <a:latin typeface="TDTD가온"/>
-                  <a:ea typeface="TDTD가온"/>
-                  <a:cs typeface="TDTD가온"/>
-                  <a:sym typeface="TDTD가온"/>
+                  <a:latin typeface="무궁화 고딕"/>
+                  <a:ea typeface="무궁화 고딕"/>
+                  <a:cs typeface="무궁화 고딕"/>
+                  <a:sym typeface="무궁화 고딕"/>
                 </a:rPr>
                 <a:t>팀원은 대표를 보호하면서</a:t>
               </a:r>
@@ -3663,18 +3659,18 @@
             <a:p>
               <a:pPr algn="l">
                 <a:lnSpc>
-                  <a:spcPts val="6275"/>
+                  <a:spcPts val="5599"/>
                 </a:lnSpc>
               </a:pPr>
               <a:r>
-                <a:rPr lang="en-US" sz="4482">
+                <a:rPr lang="en-US" sz="3999">
                   <a:solidFill>
                     <a:srgbClr val="FFFAEF"/>
                   </a:solidFill>
-                  <a:latin typeface="TDTD가온"/>
-                  <a:ea typeface="TDTD가온"/>
-                  <a:cs typeface="TDTD가온"/>
-                  <a:sym typeface="TDTD가온"/>
+                  <a:latin typeface="무궁화 고딕"/>
+                  <a:ea typeface="무궁화 고딕"/>
+                  <a:cs typeface="무궁화 고딕"/>
+                  <a:sym typeface="무궁화 고딕"/>
                 </a:rPr>
                 <a:t>상대팀 대표의 꼬리를 잡으세요!</a:t>
               </a:r>
@@ -3689,8 +3685,8 @@
           </p:nvSpPr>
           <p:spPr>
             <a:xfrm rot="0">
-              <a:off x="0" y="-171450"/>
-              <a:ext cx="7079955" cy="1169523"/>
+              <a:off x="0" y="-57150"/>
+              <a:ext cx="7079955" cy="1053161"/>
             </a:xfrm>
             <a:prstGeom prst="rect">
               <a:avLst/>
@@ -3712,10 +3708,10 @@
                   <a:solidFill>
                     <a:srgbClr val="FFFAEF"/>
                   </a:solidFill>
-                  <a:latin typeface="Jua"/>
-                  <a:ea typeface="Jua"/>
-                  <a:cs typeface="Jua"/>
-                  <a:sym typeface="Jua"/>
+                  <a:latin typeface="무궁화 고딕 Bold"/>
+                  <a:ea typeface="무궁화 고딕 Bold"/>
+                  <a:cs typeface="무궁화 고딕 Bold"/>
+                  <a:sym typeface="무궁화 고딕 Bold"/>
                 </a:rPr>
                 <a:t>STEP 2.</a:t>
               </a:r>
@@ -3763,8 +3759,8 @@
         </p:nvSpPr>
         <p:spPr>
           <a:xfrm rot="0">
-            <a:off x="3238925" y="4092795"/>
-            <a:ext cx="11810151" cy="2200275"/>
+            <a:off x="3238925" y="4378545"/>
+            <a:ext cx="11810151" cy="1914525"/>
           </a:xfrm>
           <a:prstGeom prst="rect">
             <a:avLst/>
@@ -3786,10 +3782,10 @@
                 <a:solidFill>
                   <a:srgbClr val="000000"/>
                 </a:solidFill>
-                <a:latin typeface="Jua"/>
-                <a:ea typeface="Jua"/>
-                <a:cs typeface="Jua"/>
-                <a:sym typeface="Jua"/>
+                <a:latin typeface="무궁화 고딕"/>
+                <a:ea typeface="무궁화 고딕"/>
+                <a:cs typeface="무궁화 고딕"/>
+                <a:sym typeface="무궁화 고딕"/>
               </a:rPr>
               <a:t>팀을 나눠주세요!</a:t>
             </a:r>
@@ -3936,8 +3932,8 @@
         </p:nvSpPr>
         <p:spPr>
           <a:xfrm rot="0">
-            <a:off x="1028700" y="3892867"/>
-            <a:ext cx="15555091" cy="2200275"/>
+            <a:off x="1028700" y="4178617"/>
+            <a:ext cx="15555091" cy="1914525"/>
           </a:xfrm>
           <a:prstGeom prst="rect">
             <a:avLst/>
@@ -3959,10 +3955,10 @@
                 <a:solidFill>
                   <a:srgbClr val="FFFAEF"/>
                 </a:solidFill>
-                <a:latin typeface="Jua"/>
-                <a:ea typeface="Jua"/>
-                <a:cs typeface="Jua"/>
-                <a:sym typeface="Jua"/>
+                <a:latin typeface="무궁화 고딕"/>
+                <a:ea typeface="무궁화 고딕"/>
+                <a:cs typeface="무궁화 고딕"/>
+                <a:sym typeface="무궁화 고딕"/>
               </a:rPr>
               <a:t>꼬리 잡기</a:t>
             </a:r>
@@ -3977,8 +3973,8 @@
         </p:nvSpPr>
         <p:spPr>
           <a:xfrm rot="0">
-            <a:off x="15264803" y="9812655"/>
-            <a:ext cx="2637975" cy="474345"/>
+            <a:off x="14683277" y="9822180"/>
+            <a:ext cx="3219502" cy="464820"/>
           </a:xfrm>
           <a:prstGeom prst="rect">
             <a:avLst/>
@@ -4003,10 +3999,10 @@
                 <a:solidFill>
                   <a:srgbClr val="FFFFFF"/>
                 </a:solidFill>
-                <a:latin typeface="TDTD갬성명조"/>
-                <a:ea typeface="TDTD갬성명조"/>
-                <a:cs typeface="TDTD갬성명조"/>
-                <a:sym typeface="TDTD갬성명조"/>
+                <a:latin typeface="무궁화 고딕"/>
+                <a:ea typeface="무궁화 고딕"/>
+                <a:cs typeface="무궁화 고딕"/>
+                <a:sym typeface="무궁화 고딕"/>
               </a:rPr>
               <a:t>ⓒ 2026. Sunday Play</a:t>
             </a:r>
@@ -4078,8 +4074,8 @@
         </p:nvSpPr>
         <p:spPr>
           <a:xfrm rot="0">
-            <a:off x="4421807" y="3895725"/>
-            <a:ext cx="9444385" cy="2200275"/>
+            <a:off x="4421807" y="4181475"/>
+            <a:ext cx="9444385" cy="1914525"/>
           </a:xfrm>
           <a:prstGeom prst="rect">
             <a:avLst/>
@@ -4101,10 +4097,10 @@
                 <a:solidFill>
                   <a:srgbClr val="000000"/>
                 </a:solidFill>
-                <a:latin typeface="Jua"/>
-                <a:ea typeface="Jua"/>
-                <a:cs typeface="Jua"/>
-                <a:sym typeface="Jua"/>
+                <a:latin typeface="무궁화 고딕"/>
+                <a:ea typeface="무궁화 고딕"/>
+                <a:cs typeface="무궁화 고딕"/>
+                <a:sym typeface="무궁화 고딕"/>
               </a:rPr>
               <a:t>감사합니다!</a:t>
             </a:r>

</xml_diff>